<commit_message>
feat: add CSL logo and organization details to footer
</commit_message>
<xml_diff>
--- a/public/VelTech_Day3.pptx
+++ b/public/VelTech_Day3.pptx
@@ -24,7 +24,6 @@
     <p:sldId id="272" r:id="rId19"/>
     <p:sldId id="273" r:id="rId20"/>
     <p:sldId id="274" r:id="rId21"/>
-    <p:sldId id="275" r:id="rId22"/>
   </p:sldIdLst>
   <p:sldSz cx="12192000" cy="6858000"/>
   <p:notesSz cx="6858000" cy="9144000"/>
@@ -696,63 +695,6 @@
 </file>
 
 <file path=ppt/slides/slide2.xml><?xml version="1.0" encoding="utf-8"?>
-<p:sld xmlns:a="http://schemas.openxmlformats.org/drawingml/2006/main" xmlns:r="http://schemas.openxmlformats.org/officeDocument/2006/relationships" xmlns:p="http://schemas.openxmlformats.org/presentationml/2006/main">
-  <p:cSld>
-    <p:bg>
-      <p:bgPr>
-        <a:solidFill>
-          <a:schemeClr val="bg1"/>
-        </a:solidFill>
-        <a:effectLst/>
-      </p:bgPr>
-    </p:bg>
-    <p:spTree>
-      <p:nvGrpSpPr>
-        <p:cNvPr id="1" name=""/>
-        <p:cNvGrpSpPr/>
-        <p:nvPr/>
-      </p:nvGrpSpPr>
-      <p:grpSpPr>
-        <a:xfrm>
-          <a:off x="0" y="0"/>
-          <a:ext cx="0" cy="0"/>
-          <a:chOff x="0" y="0"/>
-          <a:chExt cx="0" cy="0"/>
-        </a:xfrm>
-      </p:grpSpPr>
-      <p:pic>
-        <p:nvPicPr>
-          <p:cNvPr id="2" name="图片"/>
-          <p:cNvPicPr>
-            <a:picLocks noChangeAspect="1"/>
-          </p:cNvPicPr>
-          <p:nvPr/>
-        </p:nvPicPr>
-        <p:blipFill>
-          <a:blip r:embed="rId2">
-            <a:alphaModFix amt="100000"/>
-          </a:blip>
-          <a:srcRect l="0" t="0" r="0" b="0"/>
-          <a:stretch>
-            <a:fillRect/>
-          </a:stretch>
-        </p:blipFill>
-        <p:spPr>
-          <a:xfrm rot="0" flipH="0" flipV="0">
-            <a:off x="0" y="0"/>
-            <a:ext cx="12192000" cy="6858000"/>
-          </a:xfrm>
-          <a:prstGeom prst="rect">
-            <a:avLst/>
-          </a:prstGeom>
-        </p:spPr>
-      </p:pic>
-    </p:spTree>
-  </p:cSld>
-</p:sld>
-</file>
-
-<file path=ppt/slides/slide20.xml><?xml version="1.0" encoding="utf-8"?>
 <p:sld xmlns:a="http://schemas.openxmlformats.org/drawingml/2006/main" xmlns:r="http://schemas.openxmlformats.org/officeDocument/2006/relationships" xmlns:p="http://schemas.openxmlformats.org/presentationml/2006/main">
   <p:cSld>
     <p:bg>

</xml_diff>